<commit_message>
Revise all portfolio downloads and correct H&R premium threshold
Revise the three PRDs, two investment memos, two presentations, and two financial models for clear professional writing. Preserve requirements, financial assumptions, formulas, scenario outputs, exhibits, and download paths. Reconcile the H&R Block 20% gross IRR threshold to about 16.23% ($58.21/share), and synchronize the existing website correction note.
</commit_message>
<xml_diff>
--- a/HR_Block_PE_Investment_Committee_Pitch.pptx
+++ b/HR_Block_PE_Investment_Committee_Pitch.pptx
@@ -1738,7 +1738,7 @@
                 <a:ea typeface="Aptos" pitchFamily="34" charset="-122"/>
                 <a:cs typeface="Aptos" pitchFamily="34" charset="-120"/>
               </a:rPr>
-              <a:t>PUBLIC-TO-PRIVATE | INVESTMENT COMMITTEE</a:t>
+              <a:t>PUBLIC-TO-PRIVATE INVESTMENT COMMITTEE</a:t>
             </a:r>
             <a:endParaRPr lang="en-US" sz="1200" dirty="0"/>
           </a:p>
@@ -1820,7 +1820,7 @@
                 <a:ea typeface="Aptos" pitchFamily="34" charset="-122"/>
                 <a:cs typeface="Aptos" pitchFamily="34" charset="-120"/>
               </a:rPr>
-              <a:t>The price of predictable cash flow</a:t>
+              <a:t>Five-year leveraged buyout analysis</a:t>
             </a:r>
             <a:endParaRPr lang="en-US" sz="2400" dirty="0"/>
           </a:p>
@@ -1972,7 +1972,7 @@
                 <a:ea typeface="Aptos" pitchFamily="34" charset="-122"/>
                 <a:cs typeface="Aptos" pitchFamily="34" charset="-120"/>
               </a:rPr>
-              <a:t>16.7% modeled base IRR  |  20% investment hurdle</a:t>
+              <a:t>16.7% modeled base IRR vs. 20% investment hurdle</a:t>
             </a:r>
             <a:endParaRPr lang="en-US" sz="2200" dirty="0"/>
           </a:p>
@@ -2013,7 +2013,7 @@
                 <a:ea typeface="Aptos" pitchFamily="34" charset="-122"/>
                 <a:cs typeface="Aptos" pitchFamily="34" charset="-120"/>
               </a:rPr>
-              <a:t>Hypothetical transaction  •  22 October 2026  •  US$ millions unless noted</a:t>
+              <a:t>Hypothetical transaction. 22 October 2026. US$ millions unless noted</a:t>
             </a:r>
             <a:endParaRPr lang="en-US" sz="1100" dirty="0"/>
           </a:p>
@@ -2113,7 +2113,7 @@
                 <a:ea typeface="Aptos" pitchFamily="34" charset="-122"/>
                 <a:cs typeface="Aptos" pitchFamily="34" charset="-120"/>
               </a:rPr>
-              <a:t>PRIVATE EQUITY | INVESTMENT COMMITTEE</a:t>
+              <a:t>PRIVATE EQUITY INVESTMENT COMMITTEE</a:t>
             </a:r>
             <a:endParaRPr lang="en-US" sz="910" dirty="0"/>
           </a:p>
@@ -2154,7 +2154,7 @@
                 <a:ea typeface="Aptos" pitchFamily="34" charset="-122"/>
                 <a:cs typeface="Aptos" pitchFamily="34" charset="-120"/>
               </a:rPr>
-              <a:t>Final recommendation: pass—and retain the target on a watchlist</a:t>
+              <a:t>Recommendation: pass at the modeled entry price</a:t>
             </a:r>
             <a:endParaRPr lang="en-US" sz="2600" dirty="0"/>
           </a:p>
@@ -2218,7 +2218,7 @@
                 <a:ea typeface="Aptos" pitchFamily="34" charset="-122"/>
                 <a:cs typeface="Aptos" pitchFamily="34" charset="-120"/>
               </a:rPr>
-              <a:t>H&amp;R BLOCK  •  22 OCT 2026  •  ILLUSTRATIVE / NOT AN OFFER</a:t>
+              <a:t>H&amp;R BLOCK, 22 OCT 2026</a:t>
             </a:r>
             <a:endParaRPr lang="en-US" sz="800" dirty="0"/>
           </a:p>
@@ -2397,7 +2397,7 @@
                 <a:ea typeface="Aptos" pitchFamily="34" charset="-122"/>
                 <a:cs typeface="Aptos" pitchFamily="34" charset="-120"/>
               </a:rPr>
-              <a:t>Quality asset ≠ quality buyout</a:t>
+              <a:t>Base return falls below the hurdle</a:t>
             </a:r>
             <a:endParaRPr lang="en-US" sz="1500" dirty="0"/>
           </a:p>
@@ -2438,7 +2438,7 @@
                 <a:ea typeface="Aptos" pitchFamily="34" charset="-122"/>
                 <a:cs typeface="Aptos" pitchFamily="34" charset="-120"/>
               </a:rPr>
-              <a:t>At $8.25bn entry EV and 4.5x funded leverage, the base case earns only 16.7%.</a:t>
+              <a:t>At $8.25bn entry EV and 4.5x funded leverage, the base case earns 16.7%.</a:t>
             </a:r>
             <a:endParaRPr lang="en-US" sz="1200" dirty="0"/>
           </a:p>
@@ -2506,7 +2506,7 @@
                 <a:ea typeface="Aptos" pitchFamily="34" charset="-122"/>
                 <a:cs typeface="Aptos" pitchFamily="34" charset="-120"/>
               </a:rPr>
-              <a:t>Reopen if one of three conditions changes</a:t>
+              <a:t>Conditions for reconsideration</a:t>
             </a:r>
             <a:endParaRPr lang="en-US" sz="1500" dirty="0"/>
           </a:p>
@@ -2547,7 +2547,7 @@
                 <a:ea typeface="Aptos" pitchFamily="34" charset="-122"/>
                 <a:cs typeface="Aptos" pitchFamily="34" charset="-120"/>
               </a:rPr>
-              <a:t>Lower price (~16.5% premium), independently verified higher cash flow, or a demonstrably more attractive financing structure.</a:t>
+              <a:t>A lower price (about 16.23% premium), verified higher cash flow or better financing terms could justify reconsideration.</a:t>
             </a:r>
             <a:endParaRPr lang="en-US" sz="1200" dirty="0"/>
           </a:p>
@@ -2615,7 +2615,7 @@
                 <a:ea typeface="Aptos" pitchFamily="34" charset="-122"/>
                 <a:cs typeface="Aptos" pitchFamily="34" charset="-120"/>
               </a:rPr>
-              <a:t>Case-study diligence discipline</a:t>
+              <a:t>Further diligence</a:t>
             </a:r>
             <a:endParaRPr lang="en-US" sz="1500" dirty="0"/>
           </a:p>
@@ -2656,7 +2656,7 @@
                 <a:ea typeface="Aptos" pitchFamily="34" charset="-122"/>
                 <a:cs typeface="Aptos" pitchFamily="34" charset="-120"/>
               </a:rPr>
-              <a:t>Underwrite annualized sponsor returns, cash seasonality, lender terms and downside recovery—not just EBITDA growth.</a:t>
+              <a:t>Before investing, I would test annualized sponsor returns, seasonal cash needs, lender terms and downside recovery.</a:t>
             </a:r>
             <a:endParaRPr lang="en-US" sz="1200" dirty="0"/>
           </a:p>
@@ -2797,7 +2797,7 @@
                 <a:ea typeface="Aptos" pitchFamily="34" charset="-122"/>
                 <a:cs typeface="Aptos" pitchFamily="34" charset="-120"/>
               </a:rPr>
-              <a:t>PRIVATE EQUITY | INVESTMENT COMMITTEE</a:t>
+              <a:t>PRIVATE EQUITY INVESTMENT COMMITTEE</a:t>
             </a:r>
             <a:endParaRPr lang="en-US" sz="910" dirty="0"/>
           </a:p>
@@ -2838,7 +2838,7 @@
                 <a:ea typeface="Aptos" pitchFamily="34" charset="-122"/>
                 <a:cs typeface="Aptos" pitchFamily="34" charset="-120"/>
               </a:rPr>
-              <a:t>The investment decision</a:t>
+              <a:t>Investment recommendation</a:t>
             </a:r>
             <a:endParaRPr lang="en-US" sz="2600" dirty="0"/>
           </a:p>
@@ -2902,7 +2902,7 @@
                 <a:ea typeface="Aptos" pitchFamily="34" charset="-122"/>
                 <a:cs typeface="Aptos" pitchFamily="34" charset="-120"/>
               </a:rPr>
-              <a:t>H&amp;R BLOCK  •  22 OCT 2026  •  ILLUSTRATIVE / NOT AN OFFER</a:t>
+              <a:t>H&amp;R BLOCK, 22 OCT 2026</a:t>
             </a:r>
             <a:endParaRPr lang="en-US" sz="800" dirty="0"/>
           </a:p>
@@ -3550,7 +3550,7 @@
                 <a:ea typeface="Aptos" pitchFamily="34" charset="-122"/>
                 <a:cs typeface="Aptos" pitchFamily="34" charset="-120"/>
               </a:rPr>
-              <a:t>Investment committee verdict</a:t>
+              <a:t>Rationale</a:t>
             </a:r>
             <a:endParaRPr lang="en-US" sz="1600" dirty="0"/>
           </a:p>
@@ -3591,7 +3591,7 @@
                 <a:ea typeface="Aptos" pitchFamily="34" charset="-122"/>
                 <a:cs typeface="Aptos" pitchFamily="34" charset="-120"/>
               </a:rPr>
-              <a:t>At $62.60 per share (25% premium), financing costs and exit risk outweigh the cash-flow quality. Revisit only at a lower entry price or with demonstrated incremental free cash flow.</a:t>
+              <a:t>At $62.60 per share (25% premium), financing costs and exit risk leave the base return below the hurdle. I would reconsider at a lower price or with verified additional free cash flow.</a:t>
             </a:r>
             <a:endParaRPr lang="en-US" sz="1600" dirty="0"/>
           </a:p>
@@ -3732,7 +3732,7 @@
                 <a:ea typeface="Aptos" pitchFamily="34" charset="-122"/>
                 <a:cs typeface="Aptos" pitchFamily="34" charset="-120"/>
               </a:rPr>
-              <a:t>PRIVATE EQUITY | INVESTMENT COMMITTEE</a:t>
+              <a:t>PRIVATE EQUITY INVESTMENT COMMITTEE</a:t>
             </a:r>
             <a:endParaRPr lang="en-US" sz="910" dirty="0"/>
           </a:p>
@@ -3773,7 +3773,7 @@
                 <a:ea typeface="Aptos" pitchFamily="34" charset="-122"/>
                 <a:cs typeface="Aptos" pitchFamily="34" charset="-120"/>
               </a:rPr>
-              <a:t>A durable tax franchise—but not without substitution risk</a:t>
+              <a:t>Business fundamentals</a:t>
             </a:r>
             <a:endParaRPr lang="en-US" sz="2600" dirty="0"/>
           </a:p>
@@ -3837,7 +3837,7 @@
                 <a:ea typeface="Aptos" pitchFamily="34" charset="-122"/>
                 <a:cs typeface="Aptos" pitchFamily="34" charset="-120"/>
               </a:rPr>
-              <a:t>H&amp;R BLOCK  •  22 OCT 2026  •  ILLUSTRATIVE / NOT AN OFFER</a:t>
+              <a:t>H&amp;R BLOCK, 22 OCT 2026</a:t>
             </a:r>
             <a:endParaRPr lang="en-US" sz="800" dirty="0"/>
           </a:p>
@@ -4483,7 +4483,7 @@
                 <a:ea typeface="Aptos" pitchFamily="34" charset="-122"/>
                 <a:cs typeface="Aptos" pitchFamily="34" charset="-120"/>
               </a:rPr>
-              <a:t>Recurring compliance</a:t>
+              <a:t>Recurring tax demand</a:t>
             </a:r>
             <a:endParaRPr lang="en-US" sz="1500" dirty="0"/>
           </a:p>
@@ -4524,7 +4524,7 @@
                 <a:ea typeface="Aptos" pitchFamily="34" charset="-122"/>
                 <a:cs typeface="Aptos" pitchFamily="34" charset="-120"/>
               </a:rPr>
-              <a:t>Annual filings create habitual demand; complex customer needs support assisted tax preparation.</a:t>
+              <a:t>Annual filing requirements support recurring demand. Customers with complex returns may continue to use assisted tax preparation.</a:t>
             </a:r>
             <a:endParaRPr lang="en-US" sz="1200" dirty="0"/>
           </a:p>
@@ -4592,7 +4592,7 @@
                 <a:ea typeface="Aptos" pitchFamily="34" charset="-122"/>
                 <a:cs typeface="Aptos" pitchFamily="34" charset="-120"/>
               </a:rPr>
-              <a:t>Low reinvestment intensity</a:t>
+              <a:t>Low capital requirements</a:t>
             </a:r>
             <a:endParaRPr lang="en-US" sz="1500" dirty="0"/>
           </a:p>
@@ -4701,7 +4701,7 @@
                 <a:ea typeface="Aptos" pitchFamily="34" charset="-122"/>
                 <a:cs typeface="Aptos" pitchFamily="34" charset="-120"/>
               </a:rPr>
-              <a:t>Core tension</a:t>
+              <a:t>Pricing and volume</a:t>
             </a:r>
             <a:endParaRPr lang="en-US" sz="1500" dirty="0"/>
           </a:p>
@@ -4742,7 +4742,7 @@
                 <a:ea typeface="Aptos" pitchFamily="34" charset="-122"/>
                 <a:cs typeface="Aptos" pitchFamily="34" charset="-120"/>
               </a:rPr>
-              <a:t>Assisted revenue growth can reflect better pricing and ownership mix even with flat total assisted volume.</a:t>
+              <a:t>Higher prices and changes in ownership mix can increase assisted revenue even when total assisted volume stays flat.</a:t>
             </a:r>
             <a:endParaRPr lang="en-US" sz="1200" dirty="0"/>
           </a:p>
@@ -4883,7 +4883,7 @@
                 <a:ea typeface="Aptos" pitchFamily="34" charset="-122"/>
                 <a:cs typeface="Aptos" pitchFamily="34" charset="-120"/>
               </a:rPr>
-              <a:t>PRIVATE EQUITY | INVESTMENT COMMITTEE</a:t>
+              <a:t>PRIVATE EQUITY INVESTMENT COMMITTEE</a:t>
             </a:r>
             <a:endParaRPr lang="en-US" sz="910" dirty="0"/>
           </a:p>
@@ -4988,7 +4988,7 @@
                 <a:ea typeface="Aptos" pitchFamily="34" charset="-122"/>
                 <a:cs typeface="Aptos" pitchFamily="34" charset="-120"/>
               </a:rPr>
-              <a:t>H&amp;R BLOCK  •  22 OCT 2026  •  ILLUSTRATIVE / NOT AN OFFER</a:t>
+              <a:t>H&amp;R BLOCK, 22 OCT 2026</a:t>
             </a:r>
             <a:endParaRPr lang="en-US" sz="800" dirty="0"/>
           </a:p>
@@ -5851,7 +5851,7 @@
                 <a:ea typeface="Aptos" pitchFamily="34" charset="-122"/>
                 <a:cs typeface="Aptos" pitchFamily="34" charset="-120"/>
               </a:rPr>
-              <a:t>Senior notes: $1.58bn</a:t>
+              <a:t>Senior notes: $1.59bn</a:t>
             </a:r>
             <a:endParaRPr lang="en-US" sz="1300" dirty="0"/>
           </a:p>
@@ -6028,7 +6028,7 @@
                 <a:ea typeface="Aptos" pitchFamily="34" charset="-122"/>
                 <a:cs typeface="Aptos" pitchFamily="34" charset="-120"/>
               </a:rPr>
-              <a:t>Offer, debt sizing, fees and transaction terms are hypothetical. Sources/uses in linked Excel.</a:t>
+              <a:t>Offer, debt sizing, fees and transaction terms are hypothetical. The Excel model includes sources and uses.</a:t>
             </a:r>
             <a:endParaRPr lang="en-US" sz="820" dirty="0"/>
           </a:p>
@@ -6128,7 +6128,7 @@
                 <a:ea typeface="Aptos" pitchFamily="34" charset="-122"/>
                 <a:cs typeface="Aptos" pitchFamily="34" charset="-120"/>
               </a:rPr>
-              <a:t>PRIVATE EQUITY | INVESTMENT COMMITTEE</a:t>
+              <a:t>PRIVATE EQUITY INVESTMENT COMMITTEE</a:t>
             </a:r>
             <a:endParaRPr lang="en-US" sz="910" dirty="0"/>
           </a:p>
@@ -6169,7 +6169,7 @@
                 <a:ea typeface="Aptos" pitchFamily="34" charset="-122"/>
                 <a:cs typeface="Aptos" pitchFamily="34" charset="-120"/>
               </a:rPr>
-              <a:t>Base plan: 4% revenue growth and gradual margin gain</a:t>
+              <a:t>Base forecast: 4% growth and higher margins</a:t>
             </a:r>
             <a:endParaRPr lang="en-US" sz="2600" dirty="0"/>
           </a:p>
@@ -6233,7 +6233,7 @@
                 <a:ea typeface="Aptos" pitchFamily="34" charset="-122"/>
                 <a:cs typeface="Aptos" pitchFamily="34" charset="-120"/>
               </a:rPr>
-              <a:t>H&amp;R BLOCK  •  22 OCT 2026  •  ILLUSTRATIVE / NOT AN OFFER</a:t>
+              <a:t>H&amp;R BLOCK, 22 OCT 2026</a:t>
             </a:r>
             <a:endParaRPr lang="en-US" sz="800" dirty="0"/>
           </a:p>
@@ -7516,7 +7516,7 @@
                 <a:ea typeface="Aptos" pitchFamily="34" charset="-122"/>
                 <a:cs typeface="Aptos" pitchFamily="34" charset="-120"/>
               </a:rPr>
-              <a:t>2031 base: $4.84bn sales  •  28.2% EBITDA margin  •  $1.10bn year-end modeled cash</a:t>
+              <a:t>2031 base: $4.84bn sales, 28.2% EBITDA margin and $1.10bn year-end modeled cash</a:t>
             </a:r>
             <a:endParaRPr lang="en-US" sz="1200" dirty="0"/>
           </a:p>
@@ -7557,7 +7557,7 @@
                 <a:ea typeface="Aptos" pitchFamily="34" charset="-122"/>
                 <a:cs typeface="Aptos" pitchFamily="34" charset="-120"/>
               </a:rPr>
-              <a:t>FY2027 base uses H&amp;R Block FY2027 guidance midpoint; FY2028–2031 are analyst assumptions.</a:t>
+              <a:t>FY2027 base uses H&amp;R Block FY2027 guidance midpoint. FY2028–2031 are analyst assumptions.</a:t>
             </a:r>
             <a:endParaRPr lang="en-US" sz="820" dirty="0"/>
           </a:p>
@@ -7657,7 +7657,7 @@
                 <a:ea typeface="Aptos" pitchFamily="34" charset="-122"/>
                 <a:cs typeface="Aptos" pitchFamily="34" charset="-120"/>
               </a:rPr>
-              <a:t>PRIVATE EQUITY | INVESTMENT COMMITTEE</a:t>
+              <a:t>PRIVATE EQUITY INVESTMENT COMMITTEE</a:t>
             </a:r>
             <a:endParaRPr lang="en-US" sz="910" dirty="0"/>
           </a:p>
@@ -7698,7 +7698,7 @@
                 <a:ea typeface="Aptos" pitchFamily="34" charset="-122"/>
                 <a:cs typeface="Aptos" pitchFamily="34" charset="-120"/>
               </a:rPr>
-              <a:t>Equity creation depends on earnings growth and deleveraging</a:t>
+              <a:t>Exit equity value and sponsor proceeds</a:t>
             </a:r>
             <a:endParaRPr lang="en-US" sz="2600" dirty="0"/>
           </a:p>
@@ -7762,7 +7762,7 @@
                 <a:ea typeface="Aptos" pitchFamily="34" charset="-122"/>
                 <a:cs typeface="Aptos" pitchFamily="34" charset="-120"/>
               </a:rPr>
-              <a:t>H&amp;R BLOCK  •  22 OCT 2026  •  ILLUSTRATIVE / NOT AN OFFER</a:t>
+              <a:t>H&amp;R BLOCK, 22 OCT 2026</a:t>
             </a:r>
             <a:endParaRPr lang="en-US" sz="800" dirty="0"/>
           </a:p>
@@ -8936,7 +8936,7 @@
                 <a:ea typeface="Aptos" pitchFamily="34" charset="-122"/>
                 <a:cs typeface="Aptos" pitchFamily="34" charset="-120"/>
               </a:rPr>
-              <a:t>Cash retained after debt sweep is included in exit proceeds; seasonality and cash availability require diligence.</a:t>
+              <a:t>Exit proceeds include cash retained after the debt sweep. Seasonality and cash availability require further review.</a:t>
             </a:r>
             <a:endParaRPr lang="en-US" sz="820" dirty="0"/>
           </a:p>
@@ -9036,7 +9036,7 @@
                 <a:ea typeface="Aptos" pitchFamily="34" charset="-122"/>
                 <a:cs typeface="Aptos" pitchFamily="34" charset="-120"/>
               </a:rPr>
-              <a:t>PRIVATE EQUITY | INVESTMENT COMMITTEE</a:t>
+              <a:t>PRIVATE EQUITY INVESTMENT COMMITTEE</a:t>
             </a:r>
             <a:endParaRPr lang="en-US" sz="910" dirty="0"/>
           </a:p>
@@ -9077,7 +9077,7 @@
                 <a:ea typeface="Aptos" pitchFamily="34" charset="-122"/>
                 <a:cs typeface="Aptos" pitchFamily="34" charset="-120"/>
               </a:rPr>
-              <a:t>Return distribution: strong dispersion at the same entry price</a:t>
+              <a:t>Downside, base and upside returns</a:t>
             </a:r>
             <a:endParaRPr lang="en-US" sz="2600" dirty="0"/>
           </a:p>
@@ -9141,7 +9141,7 @@
                 <a:ea typeface="Aptos" pitchFamily="34" charset="-122"/>
                 <a:cs typeface="Aptos" pitchFamily="34" charset="-120"/>
               </a:rPr>
-              <a:t>H&amp;R BLOCK  •  22 OCT 2026  •  ILLUSTRATIVE / NOT AN OFFER</a:t>
+              <a:t>H&amp;R BLOCK, 22 OCT 2026</a:t>
             </a:r>
             <a:endParaRPr lang="en-US" sz="800" dirty="0"/>
           </a:p>
@@ -9702,7 +9702,7 @@
                 <a:ea typeface="Aptos" pitchFamily="34" charset="-122"/>
                 <a:cs typeface="Aptos" pitchFamily="34" charset="-120"/>
               </a:rPr>
-              <a:t>Illustrative exit multiples: 6.0x downside • 7.5x base • 9.0x upside</a:t>
+              <a:t>Illustrative exit multiples: 6.0x downside, 7.5x base and 9.0x upside</a:t>
             </a:r>
             <a:endParaRPr lang="en-US" sz="1200" dirty="0"/>
           </a:p>
@@ -9843,7 +9843,7 @@
                 <a:ea typeface="Aptos" pitchFamily="34" charset="-122"/>
                 <a:cs typeface="Aptos" pitchFamily="34" charset="-120"/>
               </a:rPr>
-              <a:t>PRIVATE EQUITY | INVESTMENT COMMITTEE</a:t>
+              <a:t>PRIVATE EQUITY INVESTMENT COMMITTEE</a:t>
             </a:r>
             <a:endParaRPr lang="en-US" sz="910" dirty="0"/>
           </a:p>
@@ -9884,7 +9884,7 @@
                 <a:ea typeface="Aptos" pitchFamily="34" charset="-122"/>
                 <a:cs typeface="Aptos" pitchFamily="34" charset="-120"/>
               </a:rPr>
-              <a:t>Entry discipline matters more than a good narrative</a:t>
+              <a:t>Acquisition premium sensitivity</a:t>
             </a:r>
             <a:endParaRPr lang="en-US" sz="2600" dirty="0"/>
           </a:p>
@@ -9948,7 +9948,7 @@
                 <a:ea typeface="Aptos" pitchFamily="34" charset="-122"/>
                 <a:cs typeface="Aptos" pitchFamily="34" charset="-120"/>
               </a:rPr>
-              <a:t>H&amp;R BLOCK  •  22 OCT 2026  •  ILLUSTRATIVE / NOT AN OFFER</a:t>
+              <a:t>H&amp;R BLOCK, 22 OCT 2026</a:t>
             </a:r>
             <a:endParaRPr lang="en-US" sz="800" dirty="0"/>
           </a:p>
@@ -10696,7 +10696,7 @@
                 <a:ea typeface="Aptos" pitchFamily="34" charset="-122"/>
                 <a:cs typeface="Aptos" pitchFamily="34" charset="-120"/>
               </a:rPr>
-              <a:t>~16.5% premium required to clear 20% base IRR, all else held constant</a:t>
+              <a:t>About 16.23% premium ($58.21/share) supports 20% base IRR</a:t>
             </a:r>
             <a:endParaRPr lang="en-US" sz="1300" dirty="0"/>
           </a:p>
@@ -10737,7 +10737,7 @@
                 <a:ea typeface="Aptos" pitchFamily="34" charset="-122"/>
                 <a:cs typeface="Aptos" pitchFamily="34" charset="-120"/>
               </a:rPr>
-              <a:t>Sensitivity isolates offer price; same FY2031 base operations and modeled debt paydown.</a:t>
+              <a:t>Sensitivity changes only the offer price, holding FY2031 base operations, financing assumptions and modeled debt paydown fixed.</a:t>
             </a:r>
             <a:endParaRPr lang="en-US" sz="820" dirty="0"/>
           </a:p>
@@ -10837,7 +10837,7 @@
                 <a:ea typeface="Aptos" pitchFamily="34" charset="-122"/>
                 <a:cs typeface="Aptos" pitchFamily="34" charset="-120"/>
               </a:rPr>
-              <a:t>PRIVATE EQUITY | INVESTMENT COMMITTEE</a:t>
+              <a:t>PRIVATE EQUITY INVESTMENT COMMITTEE</a:t>
             </a:r>
             <a:endParaRPr lang="en-US" sz="910" dirty="0"/>
           </a:p>
@@ -10878,7 +10878,7 @@
                 <a:ea typeface="Aptos" pitchFamily="34" charset="-122"/>
                 <a:cs typeface="Aptos" pitchFamily="34" charset="-120"/>
               </a:rPr>
-              <a:t>Risks that could break the model</a:t>
+              <a:t>Investment risks</a:t>
             </a:r>
             <a:endParaRPr lang="en-US" sz="2600" dirty="0"/>
           </a:p>
@@ -10942,7 +10942,7 @@
                 <a:ea typeface="Aptos" pitchFamily="34" charset="-122"/>
                 <a:cs typeface="Aptos" pitchFamily="34" charset="-120"/>
               </a:rPr>
-              <a:t>H&amp;R BLOCK  •  22 OCT 2026  •  ILLUSTRATIVE / NOT AN OFFER</a:t>
+              <a:t>H&amp;R BLOCK, 22 OCT 2026</a:t>
             </a:r>
             <a:endParaRPr lang="en-US" sz="800" dirty="0"/>
           </a:p>
@@ -11121,7 +11121,7 @@
                 <a:ea typeface="Aptos" pitchFamily="34" charset="-122"/>
                 <a:cs typeface="Aptos" pitchFamily="34" charset="-120"/>
               </a:rPr>
-              <a:t>February–April receipts dominate annual cash flow; monthly revolving-credit needs are omitted.</a:t>
+              <a:t>Most annual cash receipts arrive in February–April. The model omits monthly revolving-credit needs.</a:t>
             </a:r>
             <a:endParaRPr lang="en-US" sz="1200" dirty="0"/>
           </a:p>
@@ -11397,7 +11397,7 @@
                 <a:ea typeface="Aptos" pitchFamily="34" charset="-122"/>
                 <a:cs typeface="Aptos" pitchFamily="34" charset="-120"/>
               </a:rPr>
-              <a:t>8.5% first-lien / 9.5% notes are assumed, not bank commitments; covenants and tax shields are untested.</a:t>
+              <a:t>The model assumes 8.5% first-lien and 9.5% note rates without lender commitments. Covenants and tax shields require validation.</a:t>
             </a:r>
             <a:endParaRPr lang="en-US" sz="1200" dirty="0"/>
           </a:p>
@@ -11535,7 +11535,7 @@
                 <a:ea typeface="Aptos" pitchFamily="34" charset="-122"/>
                 <a:cs typeface="Aptos" pitchFamily="34" charset="-120"/>
               </a:rPr>
-              <a:t>$959mm June cash includes foreign balances; refinancing, legal exposures, and cash accessibility require review.</a:t>
+              <a:t>June cash of $959mm includes foreign balances. Refinancing, legal exposures and cash access require review.</a:t>
             </a:r>
             <a:endParaRPr lang="en-US" sz="1200" dirty="0"/>
           </a:p>
@@ -11576,7 +11576,7 @@
                 <a:ea typeface="Aptos" pitchFamily="34" charset="-122"/>
                 <a:cs typeface="Aptos" pitchFamily="34" charset="-120"/>
               </a:rPr>
-              <a:t>Tax season liquidity, real terms, and share dilution are deal-breaker diligence items.</a:t>
+              <a:t>Further diligence must establish tax-season liquidity, lender terms and the effect of share dilution.</a:t>
             </a:r>
             <a:endParaRPr lang="en-US" sz="820" dirty="0"/>
           </a:p>

</xml_diff>

<commit_message>
Revise all portfolio downloads and correct H&R premium threshold (#3)
Revise the three PRDs, two investment memos, two presentations, and two financial models for clear professional writing. Preserve requirements, financial assumptions, formulas, scenario outputs, exhibits, and download paths. Reconcile the H&R Block 20% gross IRR threshold to about 16.23% ($58.21/share), and synchronize the existing website correction note.
</commit_message>
<xml_diff>
--- a/HR_Block_PE_Investment_Committee_Pitch.pptx
+++ b/HR_Block_PE_Investment_Committee_Pitch.pptx
@@ -1738,7 +1738,7 @@
                 <a:ea typeface="Aptos" pitchFamily="34" charset="-122"/>
                 <a:cs typeface="Aptos" pitchFamily="34" charset="-120"/>
               </a:rPr>
-              <a:t>PUBLIC-TO-PRIVATE | INVESTMENT COMMITTEE</a:t>
+              <a:t>PUBLIC-TO-PRIVATE INVESTMENT COMMITTEE</a:t>
             </a:r>
             <a:endParaRPr lang="en-US" sz="1200" dirty="0"/>
           </a:p>
@@ -1820,7 +1820,7 @@
                 <a:ea typeface="Aptos" pitchFamily="34" charset="-122"/>
                 <a:cs typeface="Aptos" pitchFamily="34" charset="-120"/>
               </a:rPr>
-              <a:t>The price of predictable cash flow</a:t>
+              <a:t>Five-year leveraged buyout analysis</a:t>
             </a:r>
             <a:endParaRPr lang="en-US" sz="2400" dirty="0"/>
           </a:p>
@@ -1972,7 +1972,7 @@
                 <a:ea typeface="Aptos" pitchFamily="34" charset="-122"/>
                 <a:cs typeface="Aptos" pitchFamily="34" charset="-120"/>
               </a:rPr>
-              <a:t>16.7% modeled base IRR  |  20% investment hurdle</a:t>
+              <a:t>16.7% modeled base IRR vs. 20% investment hurdle</a:t>
             </a:r>
             <a:endParaRPr lang="en-US" sz="2200" dirty="0"/>
           </a:p>
@@ -2013,7 +2013,7 @@
                 <a:ea typeface="Aptos" pitchFamily="34" charset="-122"/>
                 <a:cs typeface="Aptos" pitchFamily="34" charset="-120"/>
               </a:rPr>
-              <a:t>Hypothetical transaction  •  22 October 2026  •  US$ millions unless noted</a:t>
+              <a:t>Hypothetical transaction. 22 October 2026. US$ millions unless noted</a:t>
             </a:r>
             <a:endParaRPr lang="en-US" sz="1100" dirty="0"/>
           </a:p>
@@ -2113,7 +2113,7 @@
                 <a:ea typeface="Aptos" pitchFamily="34" charset="-122"/>
                 <a:cs typeface="Aptos" pitchFamily="34" charset="-120"/>
               </a:rPr>
-              <a:t>PRIVATE EQUITY | INVESTMENT COMMITTEE</a:t>
+              <a:t>PRIVATE EQUITY INVESTMENT COMMITTEE</a:t>
             </a:r>
             <a:endParaRPr lang="en-US" sz="910" dirty="0"/>
           </a:p>
@@ -2154,7 +2154,7 @@
                 <a:ea typeface="Aptos" pitchFamily="34" charset="-122"/>
                 <a:cs typeface="Aptos" pitchFamily="34" charset="-120"/>
               </a:rPr>
-              <a:t>Final recommendation: pass—and retain the target on a watchlist</a:t>
+              <a:t>Recommendation: pass at the modeled entry price</a:t>
             </a:r>
             <a:endParaRPr lang="en-US" sz="2600" dirty="0"/>
           </a:p>
@@ -2218,7 +2218,7 @@
                 <a:ea typeface="Aptos" pitchFamily="34" charset="-122"/>
                 <a:cs typeface="Aptos" pitchFamily="34" charset="-120"/>
               </a:rPr>
-              <a:t>H&amp;R BLOCK  •  22 OCT 2026  •  ILLUSTRATIVE / NOT AN OFFER</a:t>
+              <a:t>H&amp;R BLOCK, 22 OCT 2026</a:t>
             </a:r>
             <a:endParaRPr lang="en-US" sz="800" dirty="0"/>
           </a:p>
@@ -2397,7 +2397,7 @@
                 <a:ea typeface="Aptos" pitchFamily="34" charset="-122"/>
                 <a:cs typeface="Aptos" pitchFamily="34" charset="-120"/>
               </a:rPr>
-              <a:t>Quality asset ≠ quality buyout</a:t>
+              <a:t>Base return falls below the hurdle</a:t>
             </a:r>
             <a:endParaRPr lang="en-US" sz="1500" dirty="0"/>
           </a:p>
@@ -2438,7 +2438,7 @@
                 <a:ea typeface="Aptos" pitchFamily="34" charset="-122"/>
                 <a:cs typeface="Aptos" pitchFamily="34" charset="-120"/>
               </a:rPr>
-              <a:t>At $8.25bn entry EV and 4.5x funded leverage, the base case earns only 16.7%.</a:t>
+              <a:t>At $8.25bn entry EV and 4.5x funded leverage, the base case earns 16.7%.</a:t>
             </a:r>
             <a:endParaRPr lang="en-US" sz="1200" dirty="0"/>
           </a:p>
@@ -2506,7 +2506,7 @@
                 <a:ea typeface="Aptos" pitchFamily="34" charset="-122"/>
                 <a:cs typeface="Aptos" pitchFamily="34" charset="-120"/>
               </a:rPr>
-              <a:t>Reopen if one of three conditions changes</a:t>
+              <a:t>Conditions for reconsideration</a:t>
             </a:r>
             <a:endParaRPr lang="en-US" sz="1500" dirty="0"/>
           </a:p>
@@ -2547,7 +2547,7 @@
                 <a:ea typeface="Aptos" pitchFamily="34" charset="-122"/>
                 <a:cs typeface="Aptos" pitchFamily="34" charset="-120"/>
               </a:rPr>
-              <a:t>Lower price (~16.5% premium), independently verified higher cash flow, or a demonstrably more attractive financing structure.</a:t>
+              <a:t>A lower price (about 16.23% premium), verified higher cash flow or better financing terms could justify reconsideration.</a:t>
             </a:r>
             <a:endParaRPr lang="en-US" sz="1200" dirty="0"/>
           </a:p>
@@ -2615,7 +2615,7 @@
                 <a:ea typeface="Aptos" pitchFamily="34" charset="-122"/>
                 <a:cs typeface="Aptos" pitchFamily="34" charset="-120"/>
               </a:rPr>
-              <a:t>Case-study diligence discipline</a:t>
+              <a:t>Further diligence</a:t>
             </a:r>
             <a:endParaRPr lang="en-US" sz="1500" dirty="0"/>
           </a:p>
@@ -2656,7 +2656,7 @@
                 <a:ea typeface="Aptos" pitchFamily="34" charset="-122"/>
                 <a:cs typeface="Aptos" pitchFamily="34" charset="-120"/>
               </a:rPr>
-              <a:t>Underwrite annualized sponsor returns, cash seasonality, lender terms and downside recovery—not just EBITDA growth.</a:t>
+              <a:t>Before investing, I would test annualized sponsor returns, seasonal cash needs, lender terms and downside recovery.</a:t>
             </a:r>
             <a:endParaRPr lang="en-US" sz="1200" dirty="0"/>
           </a:p>
@@ -2797,7 +2797,7 @@
                 <a:ea typeface="Aptos" pitchFamily="34" charset="-122"/>
                 <a:cs typeface="Aptos" pitchFamily="34" charset="-120"/>
               </a:rPr>
-              <a:t>PRIVATE EQUITY | INVESTMENT COMMITTEE</a:t>
+              <a:t>PRIVATE EQUITY INVESTMENT COMMITTEE</a:t>
             </a:r>
             <a:endParaRPr lang="en-US" sz="910" dirty="0"/>
           </a:p>
@@ -2838,7 +2838,7 @@
                 <a:ea typeface="Aptos" pitchFamily="34" charset="-122"/>
                 <a:cs typeface="Aptos" pitchFamily="34" charset="-120"/>
               </a:rPr>
-              <a:t>The investment decision</a:t>
+              <a:t>Investment recommendation</a:t>
             </a:r>
             <a:endParaRPr lang="en-US" sz="2600" dirty="0"/>
           </a:p>
@@ -2902,7 +2902,7 @@
                 <a:ea typeface="Aptos" pitchFamily="34" charset="-122"/>
                 <a:cs typeface="Aptos" pitchFamily="34" charset="-120"/>
               </a:rPr>
-              <a:t>H&amp;R BLOCK  •  22 OCT 2026  •  ILLUSTRATIVE / NOT AN OFFER</a:t>
+              <a:t>H&amp;R BLOCK, 22 OCT 2026</a:t>
             </a:r>
             <a:endParaRPr lang="en-US" sz="800" dirty="0"/>
           </a:p>
@@ -3550,7 +3550,7 @@
                 <a:ea typeface="Aptos" pitchFamily="34" charset="-122"/>
                 <a:cs typeface="Aptos" pitchFamily="34" charset="-120"/>
               </a:rPr>
-              <a:t>Investment committee verdict</a:t>
+              <a:t>Rationale</a:t>
             </a:r>
             <a:endParaRPr lang="en-US" sz="1600" dirty="0"/>
           </a:p>
@@ -3591,7 +3591,7 @@
                 <a:ea typeface="Aptos" pitchFamily="34" charset="-122"/>
                 <a:cs typeface="Aptos" pitchFamily="34" charset="-120"/>
               </a:rPr>
-              <a:t>At $62.60 per share (25% premium), financing costs and exit risk outweigh the cash-flow quality. Revisit only at a lower entry price or with demonstrated incremental free cash flow.</a:t>
+              <a:t>At $62.60 per share (25% premium), financing costs and exit risk leave the base return below the hurdle. I would reconsider at a lower price or with verified additional free cash flow.</a:t>
             </a:r>
             <a:endParaRPr lang="en-US" sz="1600" dirty="0"/>
           </a:p>
@@ -3732,7 +3732,7 @@
                 <a:ea typeface="Aptos" pitchFamily="34" charset="-122"/>
                 <a:cs typeface="Aptos" pitchFamily="34" charset="-120"/>
               </a:rPr>
-              <a:t>PRIVATE EQUITY | INVESTMENT COMMITTEE</a:t>
+              <a:t>PRIVATE EQUITY INVESTMENT COMMITTEE</a:t>
             </a:r>
             <a:endParaRPr lang="en-US" sz="910" dirty="0"/>
           </a:p>
@@ -3773,7 +3773,7 @@
                 <a:ea typeface="Aptos" pitchFamily="34" charset="-122"/>
                 <a:cs typeface="Aptos" pitchFamily="34" charset="-120"/>
               </a:rPr>
-              <a:t>A durable tax franchise—but not without substitution risk</a:t>
+              <a:t>Business fundamentals</a:t>
             </a:r>
             <a:endParaRPr lang="en-US" sz="2600" dirty="0"/>
           </a:p>
@@ -3837,7 +3837,7 @@
                 <a:ea typeface="Aptos" pitchFamily="34" charset="-122"/>
                 <a:cs typeface="Aptos" pitchFamily="34" charset="-120"/>
               </a:rPr>
-              <a:t>H&amp;R BLOCK  •  22 OCT 2026  •  ILLUSTRATIVE / NOT AN OFFER</a:t>
+              <a:t>H&amp;R BLOCK, 22 OCT 2026</a:t>
             </a:r>
             <a:endParaRPr lang="en-US" sz="800" dirty="0"/>
           </a:p>
@@ -4483,7 +4483,7 @@
                 <a:ea typeface="Aptos" pitchFamily="34" charset="-122"/>
                 <a:cs typeface="Aptos" pitchFamily="34" charset="-120"/>
               </a:rPr>
-              <a:t>Recurring compliance</a:t>
+              <a:t>Recurring tax demand</a:t>
             </a:r>
             <a:endParaRPr lang="en-US" sz="1500" dirty="0"/>
           </a:p>
@@ -4524,7 +4524,7 @@
                 <a:ea typeface="Aptos" pitchFamily="34" charset="-122"/>
                 <a:cs typeface="Aptos" pitchFamily="34" charset="-120"/>
               </a:rPr>
-              <a:t>Annual filings create habitual demand; complex customer needs support assisted tax preparation.</a:t>
+              <a:t>Annual filing requirements support recurring demand. Customers with complex returns may continue to use assisted tax preparation.</a:t>
             </a:r>
             <a:endParaRPr lang="en-US" sz="1200" dirty="0"/>
           </a:p>
@@ -4592,7 +4592,7 @@
                 <a:ea typeface="Aptos" pitchFamily="34" charset="-122"/>
                 <a:cs typeface="Aptos" pitchFamily="34" charset="-120"/>
               </a:rPr>
-              <a:t>Low reinvestment intensity</a:t>
+              <a:t>Low capital requirements</a:t>
             </a:r>
             <a:endParaRPr lang="en-US" sz="1500" dirty="0"/>
           </a:p>
@@ -4701,7 +4701,7 @@
                 <a:ea typeface="Aptos" pitchFamily="34" charset="-122"/>
                 <a:cs typeface="Aptos" pitchFamily="34" charset="-120"/>
               </a:rPr>
-              <a:t>Core tension</a:t>
+              <a:t>Pricing and volume</a:t>
             </a:r>
             <a:endParaRPr lang="en-US" sz="1500" dirty="0"/>
           </a:p>
@@ -4742,7 +4742,7 @@
                 <a:ea typeface="Aptos" pitchFamily="34" charset="-122"/>
                 <a:cs typeface="Aptos" pitchFamily="34" charset="-120"/>
               </a:rPr>
-              <a:t>Assisted revenue growth can reflect better pricing and ownership mix even with flat total assisted volume.</a:t>
+              <a:t>Higher prices and changes in ownership mix can increase assisted revenue even when total assisted volume stays flat.</a:t>
             </a:r>
             <a:endParaRPr lang="en-US" sz="1200" dirty="0"/>
           </a:p>
@@ -4883,7 +4883,7 @@
                 <a:ea typeface="Aptos" pitchFamily="34" charset="-122"/>
                 <a:cs typeface="Aptos" pitchFamily="34" charset="-120"/>
               </a:rPr>
-              <a:t>PRIVATE EQUITY | INVESTMENT COMMITTEE</a:t>
+              <a:t>PRIVATE EQUITY INVESTMENT COMMITTEE</a:t>
             </a:r>
             <a:endParaRPr lang="en-US" sz="910" dirty="0"/>
           </a:p>
@@ -4988,7 +4988,7 @@
                 <a:ea typeface="Aptos" pitchFamily="34" charset="-122"/>
                 <a:cs typeface="Aptos" pitchFamily="34" charset="-120"/>
               </a:rPr>
-              <a:t>H&amp;R BLOCK  •  22 OCT 2026  •  ILLUSTRATIVE / NOT AN OFFER</a:t>
+              <a:t>H&amp;R BLOCK, 22 OCT 2026</a:t>
             </a:r>
             <a:endParaRPr lang="en-US" sz="800" dirty="0"/>
           </a:p>
@@ -5851,7 +5851,7 @@
                 <a:ea typeface="Aptos" pitchFamily="34" charset="-122"/>
                 <a:cs typeface="Aptos" pitchFamily="34" charset="-120"/>
               </a:rPr>
-              <a:t>Senior notes: $1.58bn</a:t>
+              <a:t>Senior notes: $1.59bn</a:t>
             </a:r>
             <a:endParaRPr lang="en-US" sz="1300" dirty="0"/>
           </a:p>
@@ -6028,7 +6028,7 @@
                 <a:ea typeface="Aptos" pitchFamily="34" charset="-122"/>
                 <a:cs typeface="Aptos" pitchFamily="34" charset="-120"/>
               </a:rPr>
-              <a:t>Offer, debt sizing, fees and transaction terms are hypothetical. Sources/uses in linked Excel.</a:t>
+              <a:t>Offer, debt sizing, fees and transaction terms are hypothetical. The Excel model includes sources and uses.</a:t>
             </a:r>
             <a:endParaRPr lang="en-US" sz="820" dirty="0"/>
           </a:p>
@@ -6128,7 +6128,7 @@
                 <a:ea typeface="Aptos" pitchFamily="34" charset="-122"/>
                 <a:cs typeface="Aptos" pitchFamily="34" charset="-120"/>
               </a:rPr>
-              <a:t>PRIVATE EQUITY | INVESTMENT COMMITTEE</a:t>
+              <a:t>PRIVATE EQUITY INVESTMENT COMMITTEE</a:t>
             </a:r>
             <a:endParaRPr lang="en-US" sz="910" dirty="0"/>
           </a:p>
@@ -6169,7 +6169,7 @@
                 <a:ea typeface="Aptos" pitchFamily="34" charset="-122"/>
                 <a:cs typeface="Aptos" pitchFamily="34" charset="-120"/>
               </a:rPr>
-              <a:t>Base plan: 4% revenue growth and gradual margin gain</a:t>
+              <a:t>Base forecast: 4% growth and higher margins</a:t>
             </a:r>
             <a:endParaRPr lang="en-US" sz="2600" dirty="0"/>
           </a:p>
@@ -6233,7 +6233,7 @@
                 <a:ea typeface="Aptos" pitchFamily="34" charset="-122"/>
                 <a:cs typeface="Aptos" pitchFamily="34" charset="-120"/>
               </a:rPr>
-              <a:t>H&amp;R BLOCK  •  22 OCT 2026  •  ILLUSTRATIVE / NOT AN OFFER</a:t>
+              <a:t>H&amp;R BLOCK, 22 OCT 2026</a:t>
             </a:r>
             <a:endParaRPr lang="en-US" sz="800" dirty="0"/>
           </a:p>
@@ -7516,7 +7516,7 @@
                 <a:ea typeface="Aptos" pitchFamily="34" charset="-122"/>
                 <a:cs typeface="Aptos" pitchFamily="34" charset="-120"/>
               </a:rPr>
-              <a:t>2031 base: $4.84bn sales  •  28.2% EBITDA margin  •  $1.10bn year-end modeled cash</a:t>
+              <a:t>2031 base: $4.84bn sales, 28.2% EBITDA margin and $1.10bn year-end modeled cash</a:t>
             </a:r>
             <a:endParaRPr lang="en-US" sz="1200" dirty="0"/>
           </a:p>
@@ -7557,7 +7557,7 @@
                 <a:ea typeface="Aptos" pitchFamily="34" charset="-122"/>
                 <a:cs typeface="Aptos" pitchFamily="34" charset="-120"/>
               </a:rPr>
-              <a:t>FY2027 base uses H&amp;R Block FY2027 guidance midpoint; FY2028–2031 are analyst assumptions.</a:t>
+              <a:t>FY2027 base uses H&amp;R Block FY2027 guidance midpoint. FY2028–2031 are analyst assumptions.</a:t>
             </a:r>
             <a:endParaRPr lang="en-US" sz="820" dirty="0"/>
           </a:p>
@@ -7657,7 +7657,7 @@
                 <a:ea typeface="Aptos" pitchFamily="34" charset="-122"/>
                 <a:cs typeface="Aptos" pitchFamily="34" charset="-120"/>
               </a:rPr>
-              <a:t>PRIVATE EQUITY | INVESTMENT COMMITTEE</a:t>
+              <a:t>PRIVATE EQUITY INVESTMENT COMMITTEE</a:t>
             </a:r>
             <a:endParaRPr lang="en-US" sz="910" dirty="0"/>
           </a:p>
@@ -7698,7 +7698,7 @@
                 <a:ea typeface="Aptos" pitchFamily="34" charset="-122"/>
                 <a:cs typeface="Aptos" pitchFamily="34" charset="-120"/>
               </a:rPr>
-              <a:t>Equity creation depends on earnings growth and deleveraging</a:t>
+              <a:t>Exit equity value and sponsor proceeds</a:t>
             </a:r>
             <a:endParaRPr lang="en-US" sz="2600" dirty="0"/>
           </a:p>
@@ -7762,7 +7762,7 @@
                 <a:ea typeface="Aptos" pitchFamily="34" charset="-122"/>
                 <a:cs typeface="Aptos" pitchFamily="34" charset="-120"/>
               </a:rPr>
-              <a:t>H&amp;R BLOCK  •  22 OCT 2026  •  ILLUSTRATIVE / NOT AN OFFER</a:t>
+              <a:t>H&amp;R BLOCK, 22 OCT 2026</a:t>
             </a:r>
             <a:endParaRPr lang="en-US" sz="800" dirty="0"/>
           </a:p>
@@ -8936,7 +8936,7 @@
                 <a:ea typeface="Aptos" pitchFamily="34" charset="-122"/>
                 <a:cs typeface="Aptos" pitchFamily="34" charset="-120"/>
               </a:rPr>
-              <a:t>Cash retained after debt sweep is included in exit proceeds; seasonality and cash availability require diligence.</a:t>
+              <a:t>Exit proceeds include cash retained after the debt sweep. Seasonality and cash availability require further review.</a:t>
             </a:r>
             <a:endParaRPr lang="en-US" sz="820" dirty="0"/>
           </a:p>
@@ -9036,7 +9036,7 @@
                 <a:ea typeface="Aptos" pitchFamily="34" charset="-122"/>
                 <a:cs typeface="Aptos" pitchFamily="34" charset="-120"/>
               </a:rPr>
-              <a:t>PRIVATE EQUITY | INVESTMENT COMMITTEE</a:t>
+              <a:t>PRIVATE EQUITY INVESTMENT COMMITTEE</a:t>
             </a:r>
             <a:endParaRPr lang="en-US" sz="910" dirty="0"/>
           </a:p>
@@ -9077,7 +9077,7 @@
                 <a:ea typeface="Aptos" pitchFamily="34" charset="-122"/>
                 <a:cs typeface="Aptos" pitchFamily="34" charset="-120"/>
               </a:rPr>
-              <a:t>Return distribution: strong dispersion at the same entry price</a:t>
+              <a:t>Downside, base and upside returns</a:t>
             </a:r>
             <a:endParaRPr lang="en-US" sz="2600" dirty="0"/>
           </a:p>
@@ -9141,7 +9141,7 @@
                 <a:ea typeface="Aptos" pitchFamily="34" charset="-122"/>
                 <a:cs typeface="Aptos" pitchFamily="34" charset="-120"/>
               </a:rPr>
-              <a:t>H&amp;R BLOCK  •  22 OCT 2026  •  ILLUSTRATIVE / NOT AN OFFER</a:t>
+              <a:t>H&amp;R BLOCK, 22 OCT 2026</a:t>
             </a:r>
             <a:endParaRPr lang="en-US" sz="800" dirty="0"/>
           </a:p>
@@ -9702,7 +9702,7 @@
                 <a:ea typeface="Aptos" pitchFamily="34" charset="-122"/>
                 <a:cs typeface="Aptos" pitchFamily="34" charset="-120"/>
               </a:rPr>
-              <a:t>Illustrative exit multiples: 6.0x downside • 7.5x base • 9.0x upside</a:t>
+              <a:t>Illustrative exit multiples: 6.0x downside, 7.5x base and 9.0x upside</a:t>
             </a:r>
             <a:endParaRPr lang="en-US" sz="1200" dirty="0"/>
           </a:p>
@@ -9843,7 +9843,7 @@
                 <a:ea typeface="Aptos" pitchFamily="34" charset="-122"/>
                 <a:cs typeface="Aptos" pitchFamily="34" charset="-120"/>
               </a:rPr>
-              <a:t>PRIVATE EQUITY | INVESTMENT COMMITTEE</a:t>
+              <a:t>PRIVATE EQUITY INVESTMENT COMMITTEE</a:t>
             </a:r>
             <a:endParaRPr lang="en-US" sz="910" dirty="0"/>
           </a:p>
@@ -9884,7 +9884,7 @@
                 <a:ea typeface="Aptos" pitchFamily="34" charset="-122"/>
                 <a:cs typeface="Aptos" pitchFamily="34" charset="-120"/>
               </a:rPr>
-              <a:t>Entry discipline matters more than a good narrative</a:t>
+              <a:t>Acquisition premium sensitivity</a:t>
             </a:r>
             <a:endParaRPr lang="en-US" sz="2600" dirty="0"/>
           </a:p>
@@ -9948,7 +9948,7 @@
                 <a:ea typeface="Aptos" pitchFamily="34" charset="-122"/>
                 <a:cs typeface="Aptos" pitchFamily="34" charset="-120"/>
               </a:rPr>
-              <a:t>H&amp;R BLOCK  •  22 OCT 2026  •  ILLUSTRATIVE / NOT AN OFFER</a:t>
+              <a:t>H&amp;R BLOCK, 22 OCT 2026</a:t>
             </a:r>
             <a:endParaRPr lang="en-US" sz="800" dirty="0"/>
           </a:p>
@@ -10696,7 +10696,7 @@
                 <a:ea typeface="Aptos" pitchFamily="34" charset="-122"/>
                 <a:cs typeface="Aptos" pitchFamily="34" charset="-120"/>
               </a:rPr>
-              <a:t>~16.5% premium required to clear 20% base IRR, all else held constant</a:t>
+              <a:t>About 16.23% premium ($58.21/share) supports 20% base IRR</a:t>
             </a:r>
             <a:endParaRPr lang="en-US" sz="1300" dirty="0"/>
           </a:p>
@@ -10737,7 +10737,7 @@
                 <a:ea typeface="Aptos" pitchFamily="34" charset="-122"/>
                 <a:cs typeface="Aptos" pitchFamily="34" charset="-120"/>
               </a:rPr>
-              <a:t>Sensitivity isolates offer price; same FY2031 base operations and modeled debt paydown.</a:t>
+              <a:t>Sensitivity changes only the offer price, holding FY2031 base operations, financing assumptions and modeled debt paydown fixed.</a:t>
             </a:r>
             <a:endParaRPr lang="en-US" sz="820" dirty="0"/>
           </a:p>
@@ -10837,7 +10837,7 @@
                 <a:ea typeface="Aptos" pitchFamily="34" charset="-122"/>
                 <a:cs typeface="Aptos" pitchFamily="34" charset="-120"/>
               </a:rPr>
-              <a:t>PRIVATE EQUITY | INVESTMENT COMMITTEE</a:t>
+              <a:t>PRIVATE EQUITY INVESTMENT COMMITTEE</a:t>
             </a:r>
             <a:endParaRPr lang="en-US" sz="910" dirty="0"/>
           </a:p>
@@ -10878,7 +10878,7 @@
                 <a:ea typeface="Aptos" pitchFamily="34" charset="-122"/>
                 <a:cs typeface="Aptos" pitchFamily="34" charset="-120"/>
               </a:rPr>
-              <a:t>Risks that could break the model</a:t>
+              <a:t>Investment risks</a:t>
             </a:r>
             <a:endParaRPr lang="en-US" sz="2600" dirty="0"/>
           </a:p>
@@ -10942,7 +10942,7 @@
                 <a:ea typeface="Aptos" pitchFamily="34" charset="-122"/>
                 <a:cs typeface="Aptos" pitchFamily="34" charset="-120"/>
               </a:rPr>
-              <a:t>H&amp;R BLOCK  •  22 OCT 2026  •  ILLUSTRATIVE / NOT AN OFFER</a:t>
+              <a:t>H&amp;R BLOCK, 22 OCT 2026</a:t>
             </a:r>
             <a:endParaRPr lang="en-US" sz="800" dirty="0"/>
           </a:p>
@@ -11121,7 +11121,7 @@
                 <a:ea typeface="Aptos" pitchFamily="34" charset="-122"/>
                 <a:cs typeface="Aptos" pitchFamily="34" charset="-120"/>
               </a:rPr>
-              <a:t>February–April receipts dominate annual cash flow; monthly revolving-credit needs are omitted.</a:t>
+              <a:t>Most annual cash receipts arrive in February–April. The model omits monthly revolving-credit needs.</a:t>
             </a:r>
             <a:endParaRPr lang="en-US" sz="1200" dirty="0"/>
           </a:p>
@@ -11397,7 +11397,7 @@
                 <a:ea typeface="Aptos" pitchFamily="34" charset="-122"/>
                 <a:cs typeface="Aptos" pitchFamily="34" charset="-120"/>
               </a:rPr>
-              <a:t>8.5% first-lien / 9.5% notes are assumed, not bank commitments; covenants and tax shields are untested.</a:t>
+              <a:t>The model assumes 8.5% first-lien and 9.5% note rates without lender commitments. Covenants and tax shields require validation.</a:t>
             </a:r>
             <a:endParaRPr lang="en-US" sz="1200" dirty="0"/>
           </a:p>
@@ -11535,7 +11535,7 @@
                 <a:ea typeface="Aptos" pitchFamily="34" charset="-122"/>
                 <a:cs typeface="Aptos" pitchFamily="34" charset="-120"/>
               </a:rPr>
-              <a:t>$959mm June cash includes foreign balances; refinancing, legal exposures, and cash accessibility require review.</a:t>
+              <a:t>June cash of $959mm includes foreign balances. Refinancing, legal exposures and cash access require review.</a:t>
             </a:r>
             <a:endParaRPr lang="en-US" sz="1200" dirty="0"/>
           </a:p>
@@ -11576,7 +11576,7 @@
                 <a:ea typeface="Aptos" pitchFamily="34" charset="-122"/>
                 <a:cs typeface="Aptos" pitchFamily="34" charset="-120"/>
               </a:rPr>
-              <a:t>Tax season liquidity, real terms, and share dilution are deal-breaker diligence items.</a:t>
+              <a:t>Further diligence must establish tax-season liquidity, lender terms and the effect of share dilution.</a:t>
             </a:r>
             <a:endParaRPr lang="en-US" sz="820" dirty="0"/>
           </a:p>

</xml_diff>